<commit_message>
Remove speaking guides; sync repo with local folder
</commit_message>
<xml_diff>
--- a/presentation/Part1_Data_Pipeline.pptx
+++ b/presentation/Part1_Data_Pipeline.pptx
@@ -1844,7 +1844,7 @@
         </p:nvGraphicFramePr>
         <p:xfrm>
           <a:off x="633413" y="1530350"/>
-          <a:ext cx="9437687" cy="2279650"/>
+          <a:ext cx="9437688" cy="2279650"/>
         </p:xfrm>
         <a:graphic>
           <a:graphicData uri="http://schemas.openxmlformats.org/drawingml/2006/table">
@@ -20101,7 +20101,7 @@
         </p:nvGraphicFramePr>
         <p:xfrm>
           <a:off x="633413" y="1530350"/>
-          <a:ext cx="9437688" cy="2870200"/>
+          <a:ext cx="9437688" cy="2871216"/>
         </p:xfrm>
         <a:graphic>
           <a:graphicData uri="http://schemas.openxmlformats.org/drawingml/2006/table">
@@ -20844,7 +20844,7 @@
         </p:nvGraphicFramePr>
         <p:xfrm>
           <a:off x="622300" y="4635500"/>
-          <a:ext cx="9459913" cy="719138"/>
+          <a:ext cx="9460992" cy="719328"/>
         </p:xfrm>
         <a:graphic>
           <a:graphicData uri="http://schemas.openxmlformats.org/drawingml/2006/table">
@@ -21806,7 +21806,7 @@
         </p:nvGraphicFramePr>
         <p:xfrm>
           <a:off x="639763" y="3600450"/>
-          <a:ext cx="9424988" cy="1038225"/>
+          <a:ext cx="9424988" cy="1039368"/>
         </p:xfrm>
         <a:graphic>
           <a:graphicData uri="http://schemas.openxmlformats.org/drawingml/2006/table">
@@ -22892,15 +22892,6 @@
               </a:spcBef>
               <a:buNone/>
             </a:pPr>
-            <a:r>
-              <a:rPr sz="1300" i="1" dirty="0">
-                <a:solidFill>
-                  <a:srgbClr val="6B7280"/>
-                </a:solidFill>
-                <a:latin typeface="Arial" panose="020B0604020202020204" pitchFamily="34" charset="0"/>
-              </a:rPr>
-              <a:t>[ Insert dashboard screenshots here - severity, time patterns, weather, hotspot map, pipeline/data-quality ]</a:t>
-            </a:r>
             <a:endParaRPr sz="1300" i="1" dirty="0">
               <a:solidFill>
                 <a:srgbClr val="6B7280"/>

</xml_diff>